<commit_message>
Revise GC-MS appendix slide with lot-specific RT peak speculation
Replace generic C8–C14 bullets with this chromatogram’s labeled giants:
8.583 / 10.530 min as C10–C11 heart of the D40 cut; 3.765 min light end;
13.x min heavy end. Include the actual lot chromatogram on the slide.

Co-authored-by: rockyforever8 <rockyforever8@gmail.com>
</commit_message>
<xml_diff>
--- a/presentations/Appendix_GCMS_Peak_Findings.pptx
+++ b/presentations/Appendix_GCMS_Peak_Findings.pptx
@@ -3160,7 +3160,7 @@
                 </a:solidFill>
                 <a:latin typeface="Calibri"/>
               </a:rPr>
-              <a:t>GC-MS Peak Findings</a:t>
+              <a:t>GC-MS Peak Findings — This Lot</a:t>
             </a:r>
           </a:p>
         </p:txBody>
@@ -3194,7 +3194,7 @@
                 </a:solidFill>
                 <a:latin typeface="Calibri"/>
               </a:rPr>
-              <a:t>Appendix — major peaks on the hydrocarbon cleaner chromatogram</a:t>
+              <a:t>Speculative IDs from RT order in a C9–C11 D40 cut  •  confirm vs method + MS library</a:t>
             </a:r>
           </a:p>
         </p:txBody>
@@ -3260,7 +3260,7 @@
       </p:pic>
       <p:pic>
         <p:nvPicPr>
-          <p:cNvPr id="7" name="Picture 6" descr="gcms_curve.png"/>
+          <p:cNvPr id="7" name="Picture 6" descr="gcms_lot_chromatogram.jpg"/>
           <p:cNvPicPr>
             <a:picLocks noChangeAspect="1"/>
           </p:cNvPicPr>
@@ -3274,8 +3274,8 @@
         </p:blipFill>
         <p:spPr>
           <a:xfrm>
-            <a:off x="6446520" y="1051560"/>
-            <a:ext cx="5349240" cy="3246120"/>
+            <a:off x="6537960" y="1024128"/>
+            <a:ext cx="5257800" cy="4160520"/>
           </a:xfrm>
           <a:prstGeom prst="rect">
             <a:avLst/>
@@ -3291,8 +3291,8 @@
           <p:nvPr/>
         </p:nvGraphicFramePr>
         <p:xfrm>
-          <a:off x="502920" y="1051560"/>
-          <a:ext cx="5760720" cy="2194560"/>
+          <a:off x="411480" y="1005840"/>
+          <a:ext cx="5989320" cy="3511296"/>
         </p:xfrm>
         <a:graphic>
           <a:graphicData uri="http://schemas.openxmlformats.org/drawingml/2006/table">
@@ -3301,9 +3301,9 @@
                 <a:tableStyleId>{5C22544A-7EE6-4342-B048-85BDC9FD1C3A}</a:tableStyleId>
               </a:tblPr>
               <a:tblGrid>
-                <a:gridCol w="1188720"/>
-                <a:gridCol w="2194560"/>
-                <a:gridCol w="2377440"/>
+                <a:gridCol w="1417320"/>
+                <a:gridCol w="2148840"/>
+                <a:gridCol w="2423160"/>
               </a:tblGrid>
               <a:tr h="438912">
                 <a:tc>
@@ -3313,13 +3313,13 @@
                     <a:p>
                       <a:pPr algn="ctr"/>
                       <a:r>
-                        <a:rPr sz="1500" b="1">
+                        <a:rPr sz="1200" b="1">
                           <a:solidFill>
                             <a:srgbClr val="FFFFFF"/>
                           </a:solidFill>
                           <a:latin typeface="Calibri"/>
                         </a:rPr>
-                        <a:t>Peak</a:t>
+                        <a:t>RT (min)</a:t>
                       </a:r>
                     </a:p>
                   </a:txBody>
@@ -3336,13 +3336,13 @@
                     <a:p>
                       <a:pPr algn="ctr"/>
                       <a:r>
-                        <a:rPr sz="1500" b="1">
+                        <a:rPr sz="1200" b="1">
                           <a:solidFill>
                             <a:srgbClr val="FFFFFF"/>
                           </a:solidFill>
                           <a:latin typeface="Calibri"/>
                         </a:rPr>
-                        <a:t>What it is</a:t>
+                        <a:t>Likely family</a:t>
                       </a:r>
                     </a:p>
                   </a:txBody>
@@ -3359,13 +3359,13 @@
                     <a:p>
                       <a:pPr algn="ctr"/>
                       <a:r>
-                        <a:rPr sz="1500" b="1">
+                        <a:rPr sz="1200" b="1">
                           <a:solidFill>
                             <a:srgbClr val="FFFFFF"/>
                           </a:solidFill>
                           <a:latin typeface="Calibri"/>
                         </a:rPr>
-                        <a:t>Genuine signal</a:t>
+                        <a:t>QC reading</a:t>
                       </a:r>
                     </a:p>
                   </a:txBody>
@@ -3383,13 +3383,13 @@
                     <a:lstStyle/>
                     <a:p>
                       <a:r>
-                        <a:rPr sz="1400" b="0">
+                        <a:rPr sz="1100" b="0">
                           <a:solidFill>
                             <a:srgbClr val="141414"/>
                           </a:solidFill>
                           <a:latin typeface="Calibri"/>
                         </a:rPr>
-                        <a:t>C8</a:t>
+                        <a:t>3.765</a:t>
                       </a:r>
                     </a:p>
                   </a:txBody>
@@ -3405,13 +3405,13 @@
                     <a:lstStyle/>
                     <a:p>
                       <a:r>
-                        <a:rPr sz="1400" b="0">
+                        <a:rPr sz="1100" b="0">
                           <a:solidFill>
                             <a:srgbClr val="141414"/>
                           </a:solidFill>
                           <a:latin typeface="Calibri"/>
                         </a:rPr>
-                        <a:t>Light hydrocarbon</a:t>
+                        <a:t>C8–C9 light end (IBP)</a:t>
                       </a:r>
                     </a:p>
                   </a:txBody>
@@ -3427,13 +3427,13 @@
                     <a:lstStyle/>
                     <a:p>
                       <a:r>
-                        <a:rPr sz="1400" b="0">
+                        <a:rPr sz="1100" b="0">
                           <a:solidFill>
                             <a:srgbClr val="141414"/>
                           </a:solidFill>
                           <a:latin typeface="Calibri"/>
                         </a:rPr>
-                        <a:t>Present, even height</a:t>
+                        <a:t>Keep tiny — not MC / MeOH</a:t>
                       </a:r>
                     </a:p>
                   </a:txBody>
@@ -3451,13 +3451,13 @@
                     <a:lstStyle/>
                     <a:p>
                       <a:r>
-                        <a:rPr sz="1400" b="0">
+                        <a:rPr sz="1100" b="0">
                           <a:solidFill>
                             <a:srgbClr val="141414"/>
                           </a:solidFill>
                           <a:latin typeface="Calibri"/>
                         </a:rPr>
-                        <a:t>C10</a:t>
+                        <a:t>7.825</a:t>
                       </a:r>
                     </a:p>
                   </a:txBody>
@@ -3473,13 +3473,13 @@
                     <a:lstStyle/>
                     <a:p>
                       <a:r>
-                        <a:rPr sz="1400" b="0">
+                        <a:rPr sz="1100" b="0">
                           <a:solidFill>
                             <a:srgbClr val="141414"/>
                           </a:solidFill>
                           <a:latin typeface="Calibri"/>
                         </a:rPr>
-                        <a:t>Mid-chain</a:t>
+                        <a:t>C9 / early-C10 isomers</a:t>
                       </a:r>
                     </a:p>
                   </a:txBody>
@@ -3495,13 +3495,13 @@
                     <a:lstStyle/>
                     <a:p>
                       <a:r>
-                        <a:rPr sz="1400" b="0">
+                        <a:rPr sz="1100" b="0">
                           <a:solidFill>
                             <a:srgbClr val="141414"/>
                           </a:solidFill>
                           <a:latin typeface="Calibri"/>
                         </a:rPr>
-                        <a:t>Even spacing</a:t>
+                        <a:t>First body cluster</a:t>
                       </a:r>
                     </a:p>
                   </a:txBody>
@@ -3519,13 +3519,13 @@
                     <a:lstStyle/>
                     <a:p>
                       <a:r>
-                        <a:rPr sz="1400" b="0">
+                        <a:rPr sz="1100" b="0">
                           <a:solidFill>
                             <a:srgbClr val="141414"/>
                           </a:solidFill>
                           <a:latin typeface="Calibri"/>
                         </a:rPr>
-                        <a:t>C12</a:t>
+                        <a:t>8.583  ★</a:t>
                       </a:r>
                     </a:p>
                   </a:txBody>
@@ -3541,13 +3541,13 @@
                     <a:lstStyle/>
                     <a:p>
                       <a:r>
-                        <a:rPr sz="1400" b="0">
+                        <a:rPr sz="1100" b="0">
                           <a:solidFill>
                             <a:srgbClr val="141414"/>
                           </a:solidFill>
                           <a:latin typeface="Calibri"/>
                         </a:rPr>
-                        <a:t>Mid-chain</a:t>
+                        <a:t>C10 iso / naphthene</a:t>
                       </a:r>
                     </a:p>
                   </a:txBody>
@@ -3563,13 +3563,13 @@
                     <a:lstStyle/>
                     <a:p>
                       <a:r>
-                        <a:rPr sz="1400" b="0">
+                        <a:rPr sz="1100" b="0">
                           <a:solidFill>
                             <a:srgbClr val="141414"/>
                           </a:solidFill>
                           <a:latin typeface="Calibri"/>
                         </a:rPr>
-                        <a:t>Even spacing</a:t>
+                        <a:t>Giant — heart of the cut</a:t>
                       </a:r>
                     </a:p>
                   </a:txBody>
@@ -3587,13 +3587,13 @@
                     <a:lstStyle/>
                     <a:p>
                       <a:r>
-                        <a:rPr sz="1400" b="0">
+                        <a:rPr sz="1100" b="0">
                           <a:solidFill>
                             <a:srgbClr val="141414"/>
                           </a:solidFill>
                           <a:latin typeface="Calibri"/>
                         </a:rPr>
-                        <a:t>C14</a:t>
+                        <a:t>9.030</a:t>
                       </a:r>
                     </a:p>
                   </a:txBody>
@@ -3609,13 +3609,13 @@
                     <a:lstStyle/>
                     <a:p>
                       <a:r>
-                        <a:rPr sz="1400" b="0">
+                        <a:rPr sz="1100" b="0">
                           <a:solidFill>
                             <a:srgbClr val="141414"/>
                           </a:solidFill>
                           <a:latin typeface="Calibri"/>
                         </a:rPr>
-                        <a:t>Heavier hydrocarbon</a:t>
+                        <a:t>C10 isomer satellite</a:t>
                       </a:r>
                     </a:p>
                   </a:txBody>
@@ -3631,13 +3631,13 @@
                     <a:lstStyle/>
                     <a:p>
                       <a:r>
-                        <a:rPr sz="1400" b="0">
+                        <a:rPr sz="1100" b="0">
                           <a:solidFill>
                             <a:srgbClr val="141414"/>
                           </a:solidFill>
                           <a:latin typeface="Calibri"/>
                         </a:rPr>
-                        <a:t>Completes the fingerprint</a:t>
+                        <a:t>Should track the 8.583 giant</a:t>
                       </a:r>
                     </a:p>
                   </a:txBody>
@@ -3648,118 +3648,224 @@
                   </a:tcPr>
                 </a:tc>
               </a:tr>
+              <a:tr h="438912">
+                <a:tc>
+                  <a:txBody>
+                    <a:bodyPr/>
+                    <a:lstStyle/>
+                    <a:p>
+                      <a:r>
+                        <a:rPr sz="1100" b="0">
+                          <a:solidFill>
+                            <a:srgbClr val="141414"/>
+                          </a:solidFill>
+                          <a:latin typeface="Calibri"/>
+                        </a:rPr>
+                        <a:t>9.822 / 9.954</a:t>
+                      </a:r>
+                    </a:p>
+                  </a:txBody>
+                  <a:tcPr>
+                    <a:solidFill>
+                      <a:srgbClr val="FFFFFF"/>
+                    </a:solidFill>
+                  </a:tcPr>
+                </a:tc>
+                <a:tc>
+                  <a:txBody>
+                    <a:bodyPr/>
+                    <a:lstStyle/>
+                    <a:p>
+                      <a:r>
+                        <a:rPr sz="1100" b="0">
+                          <a:solidFill>
+                            <a:srgbClr val="141414"/>
+                          </a:solidFill>
+                          <a:latin typeface="Calibri"/>
+                        </a:rPr>
+                        <a:t>C10–C11 isomer pair</a:t>
+                      </a:r>
+                    </a:p>
+                  </a:txBody>
+                  <a:tcPr>
+                    <a:solidFill>
+                      <a:srgbClr val="FFFFFF"/>
+                    </a:solidFill>
+                  </a:tcPr>
+                </a:tc>
+                <a:tc>
+                  <a:txBody>
+                    <a:bodyPr/>
+                    <a:lstStyle/>
+                    <a:p>
+                      <a:r>
+                        <a:rPr sz="1100" b="0">
+                          <a:solidFill>
+                            <a:srgbClr val="141414"/>
+                          </a:solidFill>
+                          <a:latin typeface="Calibri"/>
+                        </a:rPr>
+                        <a:t>Adjacent boiling points</a:t>
+                      </a:r>
+                    </a:p>
+                  </a:txBody>
+                  <a:tcPr>
+                    <a:solidFill>
+                      <a:srgbClr val="FFFFFF"/>
+                    </a:solidFill>
+                  </a:tcPr>
+                </a:tc>
+              </a:tr>
+              <a:tr h="438912">
+                <a:tc>
+                  <a:txBody>
+                    <a:bodyPr/>
+                    <a:lstStyle/>
+                    <a:p>
+                      <a:r>
+                        <a:rPr sz="1100" b="0">
+                          <a:solidFill>
+                            <a:srgbClr val="141414"/>
+                          </a:solidFill>
+                          <a:latin typeface="Calibri"/>
+                        </a:rPr>
+                        <a:t>10.530  ★</a:t>
+                      </a:r>
+                    </a:p>
+                  </a:txBody>
+                  <a:tcPr>
+                    <a:solidFill>
+                      <a:srgbClr val="F7F7F7"/>
+                    </a:solidFill>
+                  </a:tcPr>
+                </a:tc>
+                <a:tc>
+                  <a:txBody>
+                    <a:bodyPr/>
+                    <a:lstStyle/>
+                    <a:p>
+                      <a:r>
+                        <a:rPr sz="1100" b="0">
+                          <a:solidFill>
+                            <a:srgbClr val="141414"/>
+                          </a:solidFill>
+                          <a:latin typeface="Calibri"/>
+                        </a:rPr>
+                        <a:t>C11 iso / naphthene</a:t>
+                      </a:r>
+                    </a:p>
+                  </a:txBody>
+                  <a:tcPr>
+                    <a:solidFill>
+                      <a:srgbClr val="F7F7F7"/>
+                    </a:solidFill>
+                  </a:tcPr>
+                </a:tc>
+                <a:tc>
+                  <a:txBody>
+                    <a:bodyPr/>
+                    <a:lstStyle/>
+                    <a:p>
+                      <a:r>
+                        <a:rPr sz="1100" b="0">
+                          <a:solidFill>
+                            <a:srgbClr val="141414"/>
+                          </a:solidFill>
+                          <a:latin typeface="Calibri"/>
+                        </a:rPr>
+                        <a:t>2nd giant — ratio vs 8.583</a:t>
+                      </a:r>
+                    </a:p>
+                  </a:txBody>
+                  <a:tcPr>
+                    <a:solidFill>
+                      <a:srgbClr val="F7F7F7"/>
+                    </a:solidFill>
+                  </a:tcPr>
+                </a:tc>
+              </a:tr>
+              <a:tr h="438912">
+                <a:tc>
+                  <a:txBody>
+                    <a:bodyPr/>
+                    <a:lstStyle/>
+                    <a:p>
+                      <a:r>
+                        <a:rPr sz="1100" b="0">
+                          <a:solidFill>
+                            <a:srgbClr val="141414"/>
+                          </a:solidFill>
+                          <a:latin typeface="Calibri"/>
+                        </a:rPr>
+                        <a:t>13.179 / 13.545</a:t>
+                      </a:r>
+                    </a:p>
+                  </a:txBody>
+                  <a:tcPr>
+                    <a:solidFill>
+                      <a:srgbClr val="FFFFFF"/>
+                    </a:solidFill>
+                  </a:tcPr>
+                </a:tc>
+                <a:tc>
+                  <a:txBody>
+                    <a:bodyPr/>
+                    <a:lstStyle/>
+                    <a:p>
+                      <a:r>
+                        <a:rPr sz="1100" b="0">
+                          <a:solidFill>
+                            <a:srgbClr val="141414"/>
+                          </a:solidFill>
+                          <a:latin typeface="Calibri"/>
+                        </a:rPr>
+                        <a:t>C11–C12 heavy end (DP)</a:t>
+                      </a:r>
+                    </a:p>
+                  </a:txBody>
+                  <a:tcPr>
+                    <a:solidFill>
+                      <a:srgbClr val="FFFFFF"/>
+                    </a:solidFill>
+                  </a:tcPr>
+                </a:tc>
+                <a:tc>
+                  <a:txBody>
+                    <a:bodyPr/>
+                    <a:lstStyle/>
+                    <a:p>
+                      <a:r>
+                        <a:rPr sz="1100" b="0">
+                          <a:solidFill>
+                            <a:srgbClr val="141414"/>
+                          </a:solidFill>
+                          <a:latin typeface="Calibri"/>
+                        </a:rPr>
+                        <a:t>Keep small — pore-residue risk</a:t>
+                      </a:r>
+                    </a:p>
+                  </a:txBody>
+                  <a:tcPr>
+                    <a:solidFill>
+                      <a:srgbClr val="FFFFFF"/>
+                    </a:solidFill>
+                  </a:tcPr>
+                </a:tc>
+              </a:tr>
             </a:tbl>
           </a:graphicData>
         </a:graphic>
       </p:graphicFrame>
       <p:sp>
         <p:nvSpPr>
-          <p:cNvPr id="9" name="TextBox 8"/>
-          <p:cNvSpPr txBox="1"/>
+          <p:cNvPr id="9" name="Rounded Rectangle 8"/>
+          <p:cNvSpPr/>
           <p:nvPr/>
         </p:nvSpPr>
         <p:spPr>
           <a:xfrm>
-            <a:off x="502920" y="4160520"/>
-            <a:ext cx="5760720" cy="4846320"/>
-          </a:xfrm>
-          <a:prstGeom prst="rect">
-            <a:avLst/>
-          </a:prstGeom>
-          <a:noFill/>
-        </p:spPr>
-        <p:txBody>
-          <a:bodyPr wrap="square">
-            <a:spAutoFit/>
-          </a:bodyPr>
-          <a:lstStyle/>
-          <a:p>
-            <a:pPr>
-              <a:spcBef>
-                <a:spcPts val="400"/>
-              </a:spcBef>
-              <a:spcAft>
-                <a:spcPts val="1600"/>
-              </a:spcAft>
-              <a:buClr>
-                <a:srgbClr val="F58220"/>
-              </a:buClr>
-              <a:buFont typeface="Calibri"/>
-              <a:buSzPts val="2800"/>
-              <a:buChar char="●"/>
-            </a:pPr>
-            <a:r>
-              <a:rPr sz="1800" b="0">
-                <a:solidFill>
-                  <a:srgbClr val="141414"/>
-                </a:solidFill>
-                <a:latin typeface="Calibri"/>
-              </a:rPr>
-              <a:t>PASS: even C8–C14 series, clean baseline</a:t>
-            </a:r>
-          </a:p>
-          <a:p>
-            <a:pPr>
-              <a:spcBef>
-                <a:spcPts val="400"/>
-              </a:spcBef>
-              <a:spcAft>
-                <a:spcPts val="1600"/>
-              </a:spcAft>
-              <a:buClr>
-                <a:srgbClr val="F58220"/>
-              </a:buClr>
-              <a:buFont typeface="Calibri"/>
-              <a:buSzPts val="2800"/>
-              <a:buChar char="●"/>
-            </a:pPr>
-            <a:r>
-              <a:rPr sz="1800" b="0">
-                <a:solidFill>
-                  <a:srgbClr val="141414"/>
-                </a:solidFill>
-                <a:latin typeface="Calibri"/>
-              </a:rPr>
-              <a:t>FAIL: extra / irregular peaks = adulterants</a:t>
-            </a:r>
-          </a:p>
-          <a:p>
-            <a:pPr>
-              <a:spcBef>
-                <a:spcPts val="400"/>
-              </a:spcBef>
-              <a:spcAft>
-                <a:spcPts val="1600"/>
-              </a:spcAft>
-              <a:buClr>
-                <a:srgbClr val="F58220"/>
-              </a:buClr>
-              <a:buFont typeface="Calibri"/>
-              <a:buSzPts val="2800"/>
-              <a:buChar char="●"/>
-            </a:pPr>
-            <a:r>
-              <a:rPr sz="1800" b="0">
-                <a:solidFill>
-                  <a:srgbClr val="141414"/>
-                </a:solidFill>
-                <a:latin typeface="Calibri"/>
-              </a:rPr>
-              <a:t>Early extra peaks → MC (~40 °C) or methanol (~65 °C)</a:t>
-            </a:r>
-          </a:p>
-        </p:txBody>
-      </p:sp>
-      <p:sp>
-        <p:nvSpPr>
-          <p:cNvPr id="10" name="Rounded Rectangle 9"/>
-          <p:cNvSpPr/>
-          <p:nvPr/>
-        </p:nvSpPr>
-        <p:spPr>
-          <a:xfrm>
-            <a:off x="502920" y="5650992"/>
-            <a:ext cx="11247120" cy="530352"/>
+            <a:off x="411480" y="5650992"/>
+            <a:ext cx="11338560" cy="530352"/>
           </a:xfrm>
           <a:prstGeom prst="roundRect">
             <a:avLst/>
@@ -3799,7 +3905,7 @@
                 </a:solidFill>
                 <a:latin typeface="Calibri"/>
               </a:rPr>
-              <a:t>Finding: genuine D40 is an even C8–C14 fingerprint. Unknown peaks are a reject — not visible by eye.</a:t>
+              <a:t>Read: two giants (8.583 &amp; 10.530 min) = D40 fingerprint. Growing 3.765 = light adulterant. Growing 13.x = wrong / wide cut.</a:t>
             </a:r>
           </a:p>
         </p:txBody>

</xml_diff>

<commit_message>
Add D60(S) GC peak speculation and D40 vs D60 chromatogram comparison
Appendix now includes this D60(S) lot (giant at 10.873 min, C10–C13) plus a
side-by-side explanation of the rightward shift, delayed start, and
unimodal vs twin-giant shape versus D40.

Co-authored-by: rockyforever8 <rockyforever8@gmail.com>
</commit_message>
<xml_diff>
--- a/presentations/Appendix_GCMS_Peak_Findings.pptx
+++ b/presentations/Appendix_GCMS_Peak_Findings.pptx
@@ -6,6 +6,8 @@
   </p:sldMasterIdLst>
   <p:sldIdLst>
     <p:sldId id="256" r:id="rId7"/>
+    <p:sldId id="257" r:id="rId8"/>
+    <p:sldId id="258" r:id="rId9"/>
   </p:sldIdLst>
   <p:sldSz cx="12191695" cy="6858000" type="screen4x3"/>
   <p:notesSz cx="6858000" cy="9144000"/>
@@ -3910,6 +3912,1566 @@
           </a:p>
         </p:txBody>
       </p:sp>
+    </p:spTree>
+  </p:cSld>
+  <p:clrMapOvr>
+    <a:masterClrMapping/>
+  </p:clrMapOvr>
+</p:sld>
+</file>
+
+<file path=ppt/slides/slide2.xml><?xml version="1.0" encoding="utf-8"?>
+<p:sld xmlns:a="http://schemas.openxmlformats.org/drawingml/2006/main" xmlns:p="http://schemas.openxmlformats.org/presentationml/2006/main" xmlns:r="http://schemas.openxmlformats.org/officeDocument/2006/relationships">
+  <p:cSld>
+    <p:spTree>
+      <p:nvGrpSpPr>
+        <p:cNvPr id="1" name=""/>
+        <p:cNvGrpSpPr/>
+        <p:nvPr/>
+      </p:nvGrpSpPr>
+      <p:grpSpPr/>
+      <p:sp>
+        <p:nvSpPr>
+          <p:cNvPr id="2" name="Rounded Rectangle 1"/>
+          <p:cNvSpPr/>
+          <p:nvPr/>
+        </p:nvSpPr>
+        <p:spPr>
+          <a:xfrm>
+            <a:off x="411480" y="292608"/>
+            <a:ext cx="502920" cy="164592"/>
+          </a:xfrm>
+          <a:prstGeom prst="roundRect">
+            <a:avLst/>
+          </a:prstGeom>
+          <a:solidFill>
+            <a:srgbClr val="F58220"/>
+          </a:solidFill>
+          <a:ln>
+            <a:noFill/>
+          </a:ln>
+        </p:spPr>
+        <p:style>
+          <a:lnRef idx="1">
+            <a:schemeClr val="accent1"/>
+          </a:lnRef>
+          <a:fillRef idx="3">
+            <a:schemeClr val="accent1"/>
+          </a:fillRef>
+          <a:effectRef idx="2">
+            <a:schemeClr val="accent1"/>
+          </a:effectRef>
+          <a:fontRef idx="minor">
+            <a:schemeClr val="lt1"/>
+          </a:fontRef>
+        </p:style>
+        <p:txBody>
+          <a:bodyPr rtlCol="0" anchor="ctr"/>
+          <a:lstStyle/>
+          <a:p>
+            <a:pPr algn="ctr"/>
+          </a:p>
+        </p:txBody>
+      </p:sp>
+      <p:sp>
+        <p:nvSpPr>
+          <p:cNvPr id="3" name="TextBox 2"/>
+          <p:cNvSpPr txBox="1"/>
+          <p:nvPr/>
+        </p:nvSpPr>
+        <p:spPr>
+          <a:xfrm>
+            <a:off x="1051560" y="164592"/>
+            <a:ext cx="10515600" cy="457200"/>
+          </a:xfrm>
+          <a:prstGeom prst="rect">
+            <a:avLst/>
+          </a:prstGeom>
+          <a:noFill/>
+        </p:spPr>
+        <p:txBody>
+          <a:bodyPr wrap="none">
+            <a:spAutoFit/>
+          </a:bodyPr>
+          <a:lstStyle/>
+          <a:p>
+            <a:r>
+              <a:rPr sz="3000" b="1">
+                <a:solidFill>
+                  <a:srgbClr val="141414"/>
+                </a:solidFill>
+                <a:latin typeface="Calibri"/>
+              </a:rPr>
+              <a:t>GC-MS Peak Findings — D60(S)</a:t>
+            </a:r>
+          </a:p>
+        </p:txBody>
+      </p:sp>
+      <p:sp>
+        <p:nvSpPr>
+          <p:cNvPr id="4" name="TextBox 3"/>
+          <p:cNvSpPr txBox="1"/>
+          <p:nvPr/>
+        </p:nvSpPr>
+        <p:spPr>
+          <a:xfrm>
+            <a:off x="1051560" y="603504"/>
+            <a:ext cx="10515600" cy="292608"/>
+          </a:xfrm>
+          <a:prstGeom prst="rect">
+            <a:avLst/>
+          </a:prstGeom>
+          <a:noFill/>
+        </p:spPr>
+        <p:txBody>
+          <a:bodyPr wrap="none">
+            <a:spAutoFit/>
+          </a:bodyPr>
+          <a:lstStyle/>
+          <a:p>
+            <a:r>
+              <a:rPr sz="1600" b="0">
+                <a:solidFill>
+                  <a:srgbClr val="5A5A5A"/>
+                </a:solidFill>
+                <a:latin typeface="Calibri"/>
+              </a:rPr>
+              <a:t>Speculative IDs from RT order in a C10–C13 D60 cut  •  confirm vs method + MS library</a:t>
+            </a:r>
+          </a:p>
+        </p:txBody>
+      </p:sp>
+      <p:sp>
+        <p:nvSpPr>
+          <p:cNvPr id="5" name="TextBox 4"/>
+          <p:cNvSpPr txBox="1"/>
+          <p:nvPr/>
+        </p:nvSpPr>
+        <p:spPr>
+          <a:xfrm>
+            <a:off x="4023360" y="6510528"/>
+            <a:ext cx="4114800" cy="256032"/>
+          </a:xfrm>
+          <a:prstGeom prst="rect">
+            <a:avLst/>
+          </a:prstGeom>
+          <a:noFill/>
+        </p:spPr>
+        <p:txBody>
+          <a:bodyPr wrap="none">
+            <a:spAutoFit/>
+          </a:bodyPr>
+          <a:lstStyle/>
+          <a:p>
+            <a:pPr algn="ctr"/>
+            <a:r>
+              <a:rPr sz="1100" b="0">
+                <a:solidFill>
+                  <a:srgbClr val="8A8A8A"/>
+                </a:solidFill>
+                <a:latin typeface="Calibri"/>
+              </a:rPr>
+              <a:t>Confidential</a:t>
+            </a:r>
+          </a:p>
+        </p:txBody>
+      </p:sp>
+      <p:pic>
+        <p:nvPicPr>
+          <p:cNvPr id="6" name="Picture 5" descr="je_logo.png"/>
+          <p:cNvPicPr>
+            <a:picLocks noChangeAspect="1"/>
+          </p:cNvPicPr>
+          <p:nvPr/>
+        </p:nvPicPr>
+        <p:blipFill>
+          <a:blip r:embed="rId2"/>
+          <a:stretch>
+            <a:fillRect/>
+          </a:stretch>
+        </p:blipFill>
+        <p:spPr>
+          <a:xfrm>
+            <a:off x="9921240" y="6263640"/>
+            <a:ext cx="1965960" cy="488890"/>
+          </a:xfrm>
+          <a:prstGeom prst="rect">
+            <a:avLst/>
+          </a:prstGeom>
+        </p:spPr>
+      </p:pic>
+      <p:pic>
+        <p:nvPicPr>
+          <p:cNvPr id="7" name="Picture 6" descr="gcms_d60_chromatogram.jpg"/>
+          <p:cNvPicPr>
+            <a:picLocks noChangeAspect="1"/>
+          </p:cNvPicPr>
+          <p:nvPr/>
+        </p:nvPicPr>
+        <p:blipFill>
+          <a:blip r:embed="rId3"/>
+          <a:stretch>
+            <a:fillRect/>
+          </a:stretch>
+        </p:blipFill>
+        <p:spPr>
+          <a:xfrm>
+            <a:off x="6537960" y="1024128"/>
+            <a:ext cx="5257800" cy="4160520"/>
+          </a:xfrm>
+          <a:prstGeom prst="rect">
+            <a:avLst/>
+          </a:prstGeom>
+        </p:spPr>
+      </p:pic>
+      <p:graphicFrame>
+        <p:nvGraphicFramePr>
+          <p:cNvPr id="8" name="Table 7"/>
+          <p:cNvGraphicFramePr>
+            <a:graphicFrameLocks noGrp="1"/>
+          </p:cNvGraphicFramePr>
+          <p:nvPr/>
+        </p:nvGraphicFramePr>
+        <p:xfrm>
+          <a:off x="411480" y="1005840"/>
+          <a:ext cx="5989320" cy="3072384"/>
+        </p:xfrm>
+        <a:graphic>
+          <a:graphicData uri="http://schemas.openxmlformats.org/drawingml/2006/table">
+            <a:tbl>
+              <a:tblPr firstRow="1" bandRow="1">
+                <a:tableStyleId>{5C22544A-7EE6-4342-B048-85BDC9FD1C3A}</a:tableStyleId>
+              </a:tblPr>
+              <a:tblGrid>
+                <a:gridCol w="1508760"/>
+                <a:gridCol w="2057400"/>
+                <a:gridCol w="2423160"/>
+              </a:tblGrid>
+              <a:tr h="438912">
+                <a:tc>
+                  <a:txBody>
+                    <a:bodyPr/>
+                    <a:lstStyle/>
+                    <a:p>
+                      <a:pPr algn="ctr"/>
+                      <a:r>
+                        <a:rPr sz="1200" b="1">
+                          <a:solidFill>
+                            <a:srgbClr val="FFFFFF"/>
+                          </a:solidFill>
+                          <a:latin typeface="Calibri"/>
+                        </a:rPr>
+                        <a:t>RT (min)</a:t>
+                      </a:r>
+                    </a:p>
+                  </a:txBody>
+                  <a:tcPr>
+                    <a:solidFill>
+                      <a:srgbClr val="F58220"/>
+                    </a:solidFill>
+                  </a:tcPr>
+                </a:tc>
+                <a:tc>
+                  <a:txBody>
+                    <a:bodyPr/>
+                    <a:lstStyle/>
+                    <a:p>
+                      <a:pPr algn="ctr"/>
+                      <a:r>
+                        <a:rPr sz="1200" b="1">
+                          <a:solidFill>
+                            <a:srgbClr val="FFFFFF"/>
+                          </a:solidFill>
+                          <a:latin typeface="Calibri"/>
+                        </a:rPr>
+                        <a:t>Likely family</a:t>
+                      </a:r>
+                    </a:p>
+                  </a:txBody>
+                  <a:tcPr>
+                    <a:solidFill>
+                      <a:srgbClr val="F58220"/>
+                    </a:solidFill>
+                  </a:tcPr>
+                </a:tc>
+                <a:tc>
+                  <a:txBody>
+                    <a:bodyPr/>
+                    <a:lstStyle/>
+                    <a:p>
+                      <a:pPr algn="ctr"/>
+                      <a:r>
+                        <a:rPr sz="1200" b="1">
+                          <a:solidFill>
+                            <a:srgbClr val="FFFFFF"/>
+                          </a:solidFill>
+                          <a:latin typeface="Calibri"/>
+                        </a:rPr>
+                        <a:t>QC reading</a:t>
+                      </a:r>
+                    </a:p>
+                  </a:txBody>
+                  <a:tcPr>
+                    <a:solidFill>
+                      <a:srgbClr val="F58220"/>
+                    </a:solidFill>
+                  </a:tcPr>
+                </a:tc>
+              </a:tr>
+              <a:tr h="438912">
+                <a:tc>
+                  <a:txBody>
+                    <a:bodyPr/>
+                    <a:lstStyle/>
+                    <a:p>
+                      <a:r>
+                        <a:rPr sz="1100" b="0">
+                          <a:solidFill>
+                            <a:srgbClr val="141414"/>
+                          </a:solidFill>
+                          <a:latin typeface="Calibri"/>
+                        </a:rPr>
+                        <a:t>5.8 – 8.9</a:t>
+                      </a:r>
+                    </a:p>
+                  </a:txBody>
+                  <a:tcPr>
+                    <a:solidFill>
+                      <a:srgbClr val="FFFFFF"/>
+                    </a:solidFill>
+                  </a:tcPr>
+                </a:tc>
+                <a:tc>
+                  <a:txBody>
+                    <a:bodyPr/>
+                    <a:lstStyle/>
+                    <a:p>
+                      <a:r>
+                        <a:rPr sz="1100" b="0">
+                          <a:solidFill>
+                            <a:srgbClr val="141414"/>
+                          </a:solidFill>
+                          <a:latin typeface="Calibri"/>
+                        </a:rPr>
+                        <a:t>C10 light front</a:t>
+                      </a:r>
+                    </a:p>
+                  </a:txBody>
+                  <a:tcPr>
+                    <a:solidFill>
+                      <a:srgbClr val="FFFFFF"/>
+                    </a:solidFill>
+                  </a:tcPr>
+                </a:tc>
+                <a:tc>
+                  <a:txBody>
+                    <a:bodyPr/>
+                    <a:lstStyle/>
+                    <a:p>
+                      <a:r>
+                        <a:rPr sz="1100" b="0">
+                          <a:solidFill>
+                            <a:srgbClr val="141414"/>
+                          </a:solidFill>
+                          <a:latin typeface="Calibri"/>
+                        </a:rPr>
+                        <a:t>Small — lights already cut</a:t>
+                      </a:r>
+                    </a:p>
+                  </a:txBody>
+                  <a:tcPr>
+                    <a:solidFill>
+                      <a:srgbClr val="FFFFFF"/>
+                    </a:solidFill>
+                  </a:tcPr>
+                </a:tc>
+              </a:tr>
+              <a:tr h="438912">
+                <a:tc>
+                  <a:txBody>
+                    <a:bodyPr/>
+                    <a:lstStyle/>
+                    <a:p>
+                      <a:r>
+                        <a:rPr sz="1100" b="0">
+                          <a:solidFill>
+                            <a:srgbClr val="141414"/>
+                          </a:solidFill>
+                          <a:latin typeface="Calibri"/>
+                        </a:rPr>
+                        <a:t>9.237 / 10.140</a:t>
+                      </a:r>
+                    </a:p>
+                  </a:txBody>
+                  <a:tcPr>
+                    <a:solidFill>
+                      <a:srgbClr val="F7F7F7"/>
+                    </a:solidFill>
+                  </a:tcPr>
+                </a:tc>
+                <a:tc>
+                  <a:txBody>
+                    <a:bodyPr/>
+                    <a:lstStyle/>
+                    <a:p>
+                      <a:r>
+                        <a:rPr sz="1100" b="0">
+                          <a:solidFill>
+                            <a:srgbClr val="141414"/>
+                          </a:solidFill>
+                          <a:latin typeface="Calibri"/>
+                        </a:rPr>
+                        <a:t>C11 isomers</a:t>
+                      </a:r>
+                    </a:p>
+                  </a:txBody>
+                  <a:tcPr>
+                    <a:solidFill>
+                      <a:srgbClr val="F7F7F7"/>
+                    </a:solidFill>
+                  </a:tcPr>
+                </a:tc>
+                <a:tc>
+                  <a:txBody>
+                    <a:bodyPr/>
+                    <a:lstStyle/>
+                    <a:p>
+                      <a:r>
+                        <a:rPr sz="1100" b="0">
+                          <a:solidFill>
+                            <a:srgbClr val="141414"/>
+                          </a:solidFill>
+                          <a:latin typeface="Calibri"/>
+                        </a:rPr>
+                        <a:t>Rising flank of the cut</a:t>
+                      </a:r>
+                    </a:p>
+                  </a:txBody>
+                  <a:tcPr>
+                    <a:solidFill>
+                      <a:srgbClr val="F7F7F7"/>
+                    </a:solidFill>
+                  </a:tcPr>
+                </a:tc>
+              </a:tr>
+              <a:tr h="438912">
+                <a:tc>
+                  <a:txBody>
+                    <a:bodyPr/>
+                    <a:lstStyle/>
+                    <a:p>
+                      <a:r>
+                        <a:rPr sz="1100" b="0">
+                          <a:solidFill>
+                            <a:srgbClr val="141414"/>
+                          </a:solidFill>
+                          <a:latin typeface="Calibri"/>
+                        </a:rPr>
+                        <a:t>10.365 / 10.556</a:t>
+                      </a:r>
+                    </a:p>
+                  </a:txBody>
+                  <a:tcPr>
+                    <a:solidFill>
+                      <a:srgbClr val="FFFFFF"/>
+                    </a:solidFill>
+                  </a:tcPr>
+                </a:tc>
+                <a:tc>
+                  <a:txBody>
+                    <a:bodyPr/>
+                    <a:lstStyle/>
+                    <a:p>
+                      <a:r>
+                        <a:rPr sz="1100" b="0">
+                          <a:solidFill>
+                            <a:srgbClr val="141414"/>
+                          </a:solidFill>
+                          <a:latin typeface="Calibri"/>
+                        </a:rPr>
+                        <a:t>C11–C12 cluster</a:t>
+                      </a:r>
+                    </a:p>
+                  </a:txBody>
+                  <a:tcPr>
+                    <a:solidFill>
+                      <a:srgbClr val="FFFFFF"/>
+                    </a:solidFill>
+                  </a:tcPr>
+                </a:tc>
+                <a:tc>
+                  <a:txBody>
+                    <a:bodyPr/>
+                    <a:lstStyle/>
+                    <a:p>
+                      <a:r>
+                        <a:rPr sz="1100" b="0">
+                          <a:solidFill>
+                            <a:srgbClr val="141414"/>
+                          </a:solidFill>
+                          <a:latin typeface="Calibri"/>
+                        </a:rPr>
+                        <a:t>Pre-giant body</a:t>
+                      </a:r>
+                    </a:p>
+                  </a:txBody>
+                  <a:tcPr>
+                    <a:solidFill>
+                      <a:srgbClr val="FFFFFF"/>
+                    </a:solidFill>
+                  </a:tcPr>
+                </a:tc>
+              </a:tr>
+              <a:tr h="438912">
+                <a:tc>
+                  <a:txBody>
+                    <a:bodyPr/>
+                    <a:lstStyle/>
+                    <a:p>
+                      <a:r>
+                        <a:rPr sz="1100" b="0">
+                          <a:solidFill>
+                            <a:srgbClr val="141414"/>
+                          </a:solidFill>
+                          <a:latin typeface="Calibri"/>
+                        </a:rPr>
+                        <a:t>10.873  ★</a:t>
+                      </a:r>
+                    </a:p>
+                  </a:txBody>
+                  <a:tcPr>
+                    <a:solidFill>
+                      <a:srgbClr val="F7F7F7"/>
+                    </a:solidFill>
+                  </a:tcPr>
+                </a:tc>
+                <a:tc>
+                  <a:txBody>
+                    <a:bodyPr/>
+                    <a:lstStyle/>
+                    <a:p>
+                      <a:r>
+                        <a:rPr sz="1100" b="0">
+                          <a:solidFill>
+                            <a:srgbClr val="141414"/>
+                          </a:solidFill>
+                          <a:latin typeface="Calibri"/>
+                        </a:rPr>
+                        <a:t>C12 iso / naphthene</a:t>
+                      </a:r>
+                    </a:p>
+                  </a:txBody>
+                  <a:tcPr>
+                    <a:solidFill>
+                      <a:srgbClr val="F7F7F7"/>
+                    </a:solidFill>
+                  </a:tcPr>
+                </a:tc>
+                <a:tc>
+                  <a:txBody>
+                    <a:bodyPr/>
+                    <a:lstStyle/>
+                    <a:p>
+                      <a:r>
+                        <a:rPr sz="1100" b="0">
+                          <a:solidFill>
+                            <a:srgbClr val="141414"/>
+                          </a:solidFill>
+                          <a:latin typeface="Calibri"/>
+                        </a:rPr>
+                        <a:t>Giant — heart of D60</a:t>
+                      </a:r>
+                    </a:p>
+                  </a:txBody>
+                  <a:tcPr>
+                    <a:solidFill>
+                      <a:srgbClr val="F7F7F7"/>
+                    </a:solidFill>
+                  </a:tcPr>
+                </a:tc>
+              </a:tr>
+              <a:tr h="438912">
+                <a:tc>
+                  <a:txBody>
+                    <a:bodyPr/>
+                    <a:lstStyle/>
+                    <a:p>
+                      <a:r>
+                        <a:rPr sz="1100" b="0">
+                          <a:solidFill>
+                            <a:srgbClr val="141414"/>
+                          </a:solidFill>
+                          <a:latin typeface="Calibri"/>
+                        </a:rPr>
+                        <a:t>11.126 / 11.514</a:t>
+                      </a:r>
+                    </a:p>
+                  </a:txBody>
+                  <a:tcPr>
+                    <a:solidFill>
+                      <a:srgbClr val="FFFFFF"/>
+                    </a:solidFill>
+                  </a:tcPr>
+                </a:tc>
+                <a:tc>
+                  <a:txBody>
+                    <a:bodyPr/>
+                    <a:lstStyle/>
+                    <a:p>
+                      <a:r>
+                        <a:rPr sz="1100" b="0">
+                          <a:solidFill>
+                            <a:srgbClr val="141414"/>
+                          </a:solidFill>
+                          <a:latin typeface="Calibri"/>
+                        </a:rPr>
+                        <a:t>C12 satellites</a:t>
+                      </a:r>
+                    </a:p>
+                  </a:txBody>
+                  <a:tcPr>
+                    <a:solidFill>
+                      <a:srgbClr val="FFFFFF"/>
+                    </a:solidFill>
+                  </a:tcPr>
+                </a:tc>
+                <a:tc>
+                  <a:txBody>
+                    <a:bodyPr/>
+                    <a:lstStyle/>
+                    <a:p>
+                      <a:r>
+                        <a:rPr sz="1100" b="0">
+                          <a:solidFill>
+                            <a:srgbClr val="141414"/>
+                          </a:solidFill>
+                          <a:latin typeface="Calibri"/>
+                        </a:rPr>
+                        <a:t>Should track 10.873</a:t>
+                      </a:r>
+                    </a:p>
+                  </a:txBody>
+                  <a:tcPr>
+                    <a:solidFill>
+                      <a:srgbClr val="FFFFFF"/>
+                    </a:solidFill>
+                  </a:tcPr>
+                </a:tc>
+              </a:tr>
+              <a:tr h="438912">
+                <a:tc>
+                  <a:txBody>
+                    <a:bodyPr/>
+                    <a:lstStyle/>
+                    <a:p>
+                      <a:r>
+                        <a:rPr sz="1100" b="0">
+                          <a:solidFill>
+                            <a:srgbClr val="141414"/>
+                          </a:solidFill>
+                          <a:latin typeface="Calibri"/>
+                        </a:rPr>
+                        <a:t>12.5 – 13.2</a:t>
+                      </a:r>
+                    </a:p>
+                  </a:txBody>
+                  <a:tcPr>
+                    <a:solidFill>
+                      <a:srgbClr val="F7F7F7"/>
+                    </a:solidFill>
+                  </a:tcPr>
+                </a:tc>
+                <a:tc>
+                  <a:txBody>
+                    <a:bodyPr/>
+                    <a:lstStyle/>
+                    <a:p>
+                      <a:r>
+                        <a:rPr sz="1100" b="0">
+                          <a:solidFill>
+                            <a:srgbClr val="141414"/>
+                          </a:solidFill>
+                          <a:latin typeface="Calibri"/>
+                        </a:rPr>
+                        <a:t>C13 heavy end (DP)</a:t>
+                      </a:r>
+                    </a:p>
+                  </a:txBody>
+                  <a:tcPr>
+                    <a:solidFill>
+                      <a:srgbClr val="F7F7F7"/>
+                    </a:solidFill>
+                  </a:tcPr>
+                </a:tc>
+                <a:tc>
+                  <a:txBody>
+                    <a:bodyPr/>
+                    <a:lstStyle/>
+                    <a:p>
+                      <a:r>
+                        <a:rPr sz="1100" b="0">
+                          <a:solidFill>
+                            <a:srgbClr val="141414"/>
+                          </a:solidFill>
+                          <a:latin typeface="Calibri"/>
+                        </a:rPr>
+                        <a:t>Keep small — slow dry</a:t>
+                      </a:r>
+                    </a:p>
+                  </a:txBody>
+                  <a:tcPr>
+                    <a:solidFill>
+                      <a:srgbClr val="F7F7F7"/>
+                    </a:solidFill>
+                  </a:tcPr>
+                </a:tc>
+              </a:tr>
+            </a:tbl>
+          </a:graphicData>
+        </a:graphic>
+      </p:graphicFrame>
+      <p:sp>
+        <p:nvSpPr>
+          <p:cNvPr id="9" name="Rounded Rectangle 8"/>
+          <p:cNvSpPr/>
+          <p:nvPr/>
+        </p:nvSpPr>
+        <p:spPr>
+          <a:xfrm>
+            <a:off x="411480" y="5650992"/>
+            <a:ext cx="11338560" cy="530352"/>
+          </a:xfrm>
+          <a:prstGeom prst="roundRect">
+            <a:avLst/>
+          </a:prstGeom>
+          <a:solidFill>
+            <a:srgbClr val="FDE8D0"/>
+          </a:solidFill>
+          <a:ln w="15875">
+            <a:solidFill>
+              <a:srgbClr val="F58220"/>
+            </a:solidFill>
+          </a:ln>
+        </p:spPr>
+        <p:style>
+          <a:lnRef idx="1">
+            <a:schemeClr val="accent1"/>
+          </a:lnRef>
+          <a:fillRef idx="3">
+            <a:schemeClr val="accent1"/>
+          </a:fillRef>
+          <a:effectRef idx="2">
+            <a:schemeClr val="accent1"/>
+          </a:effectRef>
+          <a:fontRef idx="minor">
+            <a:schemeClr val="lt1"/>
+          </a:fontRef>
+        </p:style>
+        <p:txBody>
+          <a:bodyPr rtlCol="0" anchor="ctr" wrap="square" lIns="164592"/>
+          <a:lstStyle/>
+          <a:p>
+            <a:pPr algn="l"/>
+            <a:r>
+              <a:rPr sz="1600" b="1">
+                <a:solidFill>
+                  <a:srgbClr val="141414"/>
+                </a:solidFill>
+                <a:latin typeface="Calibri"/>
+              </a:rPr>
+              <a:t>Read: D60 heart is one mountain at 10.873 min — not D40’s twin giants at 8.58 / 10.53. Envelope starts ~2 min later.</a:t>
+            </a:r>
+          </a:p>
+        </p:txBody>
+      </p:sp>
+    </p:spTree>
+  </p:cSld>
+  <p:clrMapOvr>
+    <a:masterClrMapping/>
+  </p:clrMapOvr>
+</p:sld>
+</file>
+
+<file path=ppt/slides/slide3.xml><?xml version="1.0" encoding="utf-8"?>
+<p:sld xmlns:a="http://schemas.openxmlformats.org/drawingml/2006/main" xmlns:p="http://schemas.openxmlformats.org/presentationml/2006/main" xmlns:r="http://schemas.openxmlformats.org/officeDocument/2006/relationships">
+  <p:cSld>
+    <p:spTree>
+      <p:nvGrpSpPr>
+        <p:cNvPr id="1" name=""/>
+        <p:cNvGrpSpPr/>
+        <p:nvPr/>
+      </p:nvGrpSpPr>
+      <p:grpSpPr/>
+      <p:sp>
+        <p:nvSpPr>
+          <p:cNvPr id="2" name="Rounded Rectangle 1"/>
+          <p:cNvSpPr/>
+          <p:nvPr/>
+        </p:nvSpPr>
+        <p:spPr>
+          <a:xfrm>
+            <a:off x="411480" y="292608"/>
+            <a:ext cx="502920" cy="164592"/>
+          </a:xfrm>
+          <a:prstGeom prst="roundRect">
+            <a:avLst/>
+          </a:prstGeom>
+          <a:solidFill>
+            <a:srgbClr val="F58220"/>
+          </a:solidFill>
+          <a:ln>
+            <a:noFill/>
+          </a:ln>
+        </p:spPr>
+        <p:style>
+          <a:lnRef idx="1">
+            <a:schemeClr val="accent1"/>
+          </a:lnRef>
+          <a:fillRef idx="3">
+            <a:schemeClr val="accent1"/>
+          </a:fillRef>
+          <a:effectRef idx="2">
+            <a:schemeClr val="accent1"/>
+          </a:effectRef>
+          <a:fontRef idx="minor">
+            <a:schemeClr val="lt1"/>
+          </a:fontRef>
+        </p:style>
+        <p:txBody>
+          <a:bodyPr rtlCol="0" anchor="ctr"/>
+          <a:lstStyle/>
+          <a:p>
+            <a:pPr algn="ctr"/>
+          </a:p>
+        </p:txBody>
+      </p:sp>
+      <p:sp>
+        <p:nvSpPr>
+          <p:cNvPr id="3" name="TextBox 2"/>
+          <p:cNvSpPr txBox="1"/>
+          <p:nvPr/>
+        </p:nvSpPr>
+        <p:spPr>
+          <a:xfrm>
+            <a:off x="1051560" y="164592"/>
+            <a:ext cx="10515600" cy="457200"/>
+          </a:xfrm>
+          <a:prstGeom prst="rect">
+            <a:avLst/>
+          </a:prstGeom>
+          <a:noFill/>
+        </p:spPr>
+        <p:txBody>
+          <a:bodyPr wrap="none">
+            <a:spAutoFit/>
+          </a:bodyPr>
+          <a:lstStyle/>
+          <a:p>
+            <a:r>
+              <a:rPr sz="3000" b="1">
+                <a:solidFill>
+                  <a:srgbClr val="141414"/>
+                </a:solidFill>
+                <a:latin typeface="Calibri"/>
+              </a:rPr>
+              <a:t>D40 vs D60(S) — Why the Charts Differ</a:t>
+            </a:r>
+          </a:p>
+        </p:txBody>
+      </p:sp>
+      <p:sp>
+        <p:nvSpPr>
+          <p:cNvPr id="4" name="TextBox 3"/>
+          <p:cNvSpPr txBox="1"/>
+          <p:nvPr/>
+        </p:nvSpPr>
+        <p:spPr>
+          <a:xfrm>
+            <a:off x="1051560" y="603504"/>
+            <a:ext cx="10515600" cy="292608"/>
+          </a:xfrm>
+          <a:prstGeom prst="rect">
+            <a:avLst/>
+          </a:prstGeom>
+          <a:noFill/>
+        </p:spPr>
+        <p:txBody>
+          <a:bodyPr wrap="none">
+            <a:spAutoFit/>
+          </a:bodyPr>
+          <a:lstStyle/>
+          <a:p>
+            <a:r>
+              <a:rPr sz="1600" b="0">
+                <a:solidFill>
+                  <a:srgbClr val="5A5A5A"/>
+                </a:solidFill>
+                <a:latin typeface="Calibri"/>
+              </a:rPr>
+              <a:t>Same GC principle: heavier molecules spend longer on the column</a:t>
+            </a:r>
+          </a:p>
+        </p:txBody>
+      </p:sp>
+      <p:sp>
+        <p:nvSpPr>
+          <p:cNvPr id="5" name="TextBox 4"/>
+          <p:cNvSpPr txBox="1"/>
+          <p:nvPr/>
+        </p:nvSpPr>
+        <p:spPr>
+          <a:xfrm>
+            <a:off x="4023360" y="6510528"/>
+            <a:ext cx="4114800" cy="256032"/>
+          </a:xfrm>
+          <a:prstGeom prst="rect">
+            <a:avLst/>
+          </a:prstGeom>
+          <a:noFill/>
+        </p:spPr>
+        <p:txBody>
+          <a:bodyPr wrap="none">
+            <a:spAutoFit/>
+          </a:bodyPr>
+          <a:lstStyle/>
+          <a:p>
+            <a:pPr algn="ctr"/>
+            <a:r>
+              <a:rPr sz="1100" b="0">
+                <a:solidFill>
+                  <a:srgbClr val="8A8A8A"/>
+                </a:solidFill>
+                <a:latin typeface="Calibri"/>
+              </a:rPr>
+              <a:t>Confidential</a:t>
+            </a:r>
+          </a:p>
+        </p:txBody>
+      </p:sp>
+      <p:pic>
+        <p:nvPicPr>
+          <p:cNvPr id="6" name="Picture 5" descr="je_logo.png"/>
+          <p:cNvPicPr>
+            <a:picLocks noChangeAspect="1"/>
+          </p:cNvPicPr>
+          <p:nvPr/>
+        </p:nvPicPr>
+        <p:blipFill>
+          <a:blip r:embed="rId2"/>
+          <a:stretch>
+            <a:fillRect/>
+          </a:stretch>
+        </p:blipFill>
+        <p:spPr>
+          <a:xfrm>
+            <a:off x="9921240" y="6263640"/>
+            <a:ext cx="1965960" cy="488890"/>
+          </a:xfrm>
+          <a:prstGeom prst="rect">
+            <a:avLst/>
+          </a:prstGeom>
+        </p:spPr>
+      </p:pic>
+      <p:pic>
+        <p:nvPicPr>
+          <p:cNvPr id="7" name="Picture 6" descr="gcms_lot_chromatogram.jpg"/>
+          <p:cNvPicPr>
+            <a:picLocks noChangeAspect="1"/>
+          </p:cNvPicPr>
+          <p:nvPr/>
+        </p:nvPicPr>
+        <p:blipFill>
+          <a:blip r:embed="rId3"/>
+          <a:stretch>
+            <a:fillRect/>
+          </a:stretch>
+        </p:blipFill>
+        <p:spPr>
+          <a:xfrm>
+            <a:off x="411480" y="1024128"/>
+            <a:ext cx="5623560" cy="2331720"/>
+          </a:xfrm>
+          <a:prstGeom prst="rect">
+            <a:avLst/>
+          </a:prstGeom>
+        </p:spPr>
+      </p:pic>
+      <p:pic>
+        <p:nvPicPr>
+          <p:cNvPr id="8" name="Picture 7" descr="gcms_d60_chromatogram.jpg"/>
+          <p:cNvPicPr>
+            <a:picLocks noChangeAspect="1"/>
+          </p:cNvPicPr>
+          <p:nvPr/>
+        </p:nvPicPr>
+        <p:blipFill>
+          <a:blip r:embed="rId4"/>
+          <a:stretch>
+            <a:fillRect/>
+          </a:stretch>
+        </p:blipFill>
+        <p:spPr>
+          <a:xfrm>
+            <a:off x="6172200" y="1024128"/>
+            <a:ext cx="5623560" cy="2331720"/>
+          </a:xfrm>
+          <a:prstGeom prst="rect">
+            <a:avLst/>
+          </a:prstGeom>
+        </p:spPr>
+      </p:pic>
+      <p:sp>
+        <p:nvSpPr>
+          <p:cNvPr id="9" name="TextBox 8"/>
+          <p:cNvSpPr txBox="1"/>
+          <p:nvPr/>
+        </p:nvSpPr>
+        <p:spPr>
+          <a:xfrm>
+            <a:off x="411480" y="3364992"/>
+            <a:ext cx="5623560" cy="292608"/>
+          </a:xfrm>
+          <a:prstGeom prst="rect">
+            <a:avLst/>
+          </a:prstGeom>
+          <a:noFill/>
+        </p:spPr>
+        <p:txBody>
+          <a:bodyPr wrap="none">
+            <a:spAutoFit/>
+          </a:bodyPr>
+          <a:lstStyle/>
+          <a:p>
+            <a:pPr algn="ctr"/>
+            <a:r>
+              <a:rPr sz="1400" b="1">
+                <a:solidFill>
+                  <a:srgbClr val="F58220"/>
+                </a:solidFill>
+                <a:latin typeface="Calibri"/>
+              </a:rPr>
+              <a:t>D40  •  giants 8.583 &amp; 10.530 min  •  C9–C11</a:t>
+            </a:r>
+          </a:p>
+        </p:txBody>
+      </p:sp>
+      <p:sp>
+        <p:nvSpPr>
+          <p:cNvPr id="10" name="TextBox 9"/>
+          <p:cNvSpPr txBox="1"/>
+          <p:nvPr/>
+        </p:nvSpPr>
+        <p:spPr>
+          <a:xfrm>
+            <a:off x="6172200" y="3364992"/>
+            <a:ext cx="5623560" cy="292608"/>
+          </a:xfrm>
+          <a:prstGeom prst="rect">
+            <a:avLst/>
+          </a:prstGeom>
+          <a:noFill/>
+        </p:spPr>
+        <p:txBody>
+          <a:bodyPr wrap="none">
+            <a:spAutoFit/>
+          </a:bodyPr>
+          <a:lstStyle/>
+          <a:p>
+            <a:pPr algn="ctr"/>
+            <a:r>
+              <a:rPr sz="1400" b="1">
+                <a:solidFill>
+                  <a:srgbClr val="F58220"/>
+                </a:solidFill>
+                <a:latin typeface="Calibri"/>
+              </a:rPr>
+              <a:t>D60(S)  •  giant 10.873 min  •  C10–C13</a:t>
+            </a:r>
+          </a:p>
+        </p:txBody>
+      </p:sp>
+      <p:graphicFrame>
+        <p:nvGraphicFramePr>
+          <p:cNvPr id="11" name="Table 10"/>
+          <p:cNvGraphicFramePr>
+            <a:graphicFrameLocks noGrp="1"/>
+          </p:cNvGraphicFramePr>
+          <p:nvPr/>
+        </p:nvGraphicFramePr>
+        <p:xfrm>
+          <a:off x="411480" y="3703320"/>
+          <a:ext cx="11384280" cy="2194560"/>
+        </p:xfrm>
+        <a:graphic>
+          <a:graphicData uri="http://schemas.openxmlformats.org/drawingml/2006/table">
+            <a:tbl>
+              <a:tblPr firstRow="1" bandRow="1">
+                <a:tableStyleId>{5C22544A-7EE6-4342-B048-85BDC9FD1C3A}</a:tableStyleId>
+              </a:tblPr>
+              <a:tblGrid>
+                <a:gridCol w="1920240"/>
+                <a:gridCol w="2468880"/>
+                <a:gridCol w="2651760"/>
+                <a:gridCol w="4343400"/>
+              </a:tblGrid>
+              <a:tr h="438912">
+                <a:tc>
+                  <a:txBody>
+                    <a:bodyPr/>
+                    <a:lstStyle/>
+                    <a:p>
+                      <a:pPr algn="ctr"/>
+                      <a:r>
+                        <a:rPr sz="1300" b="1">
+                          <a:solidFill>
+                            <a:srgbClr val="FFFFFF"/>
+                          </a:solidFill>
+                          <a:latin typeface="Calibri"/>
+                        </a:rPr>
+                        <a:t>Feature</a:t>
+                      </a:r>
+                    </a:p>
+                  </a:txBody>
+                  <a:tcPr>
+                    <a:solidFill>
+                      <a:srgbClr val="F58220"/>
+                    </a:solidFill>
+                  </a:tcPr>
+                </a:tc>
+                <a:tc>
+                  <a:txBody>
+                    <a:bodyPr/>
+                    <a:lstStyle/>
+                    <a:p>
+                      <a:pPr algn="ctr"/>
+                      <a:r>
+                        <a:rPr sz="1300" b="1">
+                          <a:solidFill>
+                            <a:srgbClr val="FFFFFF"/>
+                          </a:solidFill>
+                          <a:latin typeface="Calibri"/>
+                        </a:rPr>
+                        <a:t>D40</a:t>
+                      </a:r>
+                    </a:p>
+                  </a:txBody>
+                  <a:tcPr>
+                    <a:solidFill>
+                      <a:srgbClr val="F58220"/>
+                    </a:solidFill>
+                  </a:tcPr>
+                </a:tc>
+                <a:tc>
+                  <a:txBody>
+                    <a:bodyPr/>
+                    <a:lstStyle/>
+                    <a:p>
+                      <a:pPr algn="ctr"/>
+                      <a:r>
+                        <a:rPr sz="1300" b="1">
+                          <a:solidFill>
+                            <a:srgbClr val="FFFFFF"/>
+                          </a:solidFill>
+                          <a:latin typeface="Calibri"/>
+                        </a:rPr>
+                        <a:t>D60(S)</a:t>
+                      </a:r>
+                    </a:p>
+                  </a:txBody>
+                  <a:tcPr>
+                    <a:solidFill>
+                      <a:srgbClr val="F58220"/>
+                    </a:solidFill>
+                  </a:tcPr>
+                </a:tc>
+                <a:tc>
+                  <a:txBody>
+                    <a:bodyPr/>
+                    <a:lstStyle/>
+                    <a:p>
+                      <a:pPr algn="ctr"/>
+                      <a:r>
+                        <a:rPr sz="1300" b="1">
+                          <a:solidFill>
+                            <a:srgbClr val="FFFFFF"/>
+                          </a:solidFill>
+                          <a:latin typeface="Calibri"/>
+                        </a:rPr>
+                        <a:t>Logical reason</a:t>
+                      </a:r>
+                    </a:p>
+                  </a:txBody>
+                  <a:tcPr>
+                    <a:solidFill>
+                      <a:srgbClr val="F58220"/>
+                    </a:solidFill>
+                  </a:tcPr>
+                </a:tc>
+              </a:tr>
+              <a:tr h="438912">
+                <a:tc>
+                  <a:txBody>
+                    <a:bodyPr/>
+                    <a:lstStyle/>
+                    <a:p>
+                      <a:r>
+                        <a:rPr sz="1200" b="0">
+                          <a:solidFill>
+                            <a:srgbClr val="141414"/>
+                          </a:solidFill>
+                          <a:latin typeface="Calibri"/>
+                        </a:rPr>
+                        <a:t>Envelope start</a:t>
+                      </a:r>
+                    </a:p>
+                  </a:txBody>
+                  <a:tcPr>
+                    <a:solidFill>
+                      <a:srgbClr val="FFFFFF"/>
+                    </a:solidFill>
+                  </a:tcPr>
+                </a:tc>
+                <a:tc>
+                  <a:txBody>
+                    <a:bodyPr/>
+                    <a:lstStyle/>
+                    <a:p>
+                      <a:r>
+                        <a:rPr sz="1200" b="0">
+                          <a:solidFill>
+                            <a:srgbClr val="141414"/>
+                          </a:solidFill>
+                          <a:latin typeface="Calibri"/>
+                        </a:rPr>
+                        <a:t>~3.8 min</a:t>
+                      </a:r>
+                    </a:p>
+                  </a:txBody>
+                  <a:tcPr>
+                    <a:solidFill>
+                      <a:srgbClr val="FFFFFF"/>
+                    </a:solidFill>
+                  </a:tcPr>
+                </a:tc>
+                <a:tc>
+                  <a:txBody>
+                    <a:bodyPr/>
+                    <a:lstStyle/>
+                    <a:p>
+                      <a:r>
+                        <a:rPr sz="1200" b="0">
+                          <a:solidFill>
+                            <a:srgbClr val="141414"/>
+                          </a:solidFill>
+                          <a:latin typeface="Calibri"/>
+                        </a:rPr>
+                        <a:t>~5.8 min</a:t>
+                      </a:r>
+                    </a:p>
+                  </a:txBody>
+                  <a:tcPr>
+                    <a:solidFill>
+                      <a:srgbClr val="FFFFFF"/>
+                    </a:solidFill>
+                  </a:tcPr>
+                </a:tc>
+                <a:tc>
+                  <a:txBody>
+                    <a:bodyPr/>
+                    <a:lstStyle/>
+                    <a:p>
+                      <a:r>
+                        <a:rPr sz="1200" b="0">
+                          <a:solidFill>
+                            <a:srgbClr val="141414"/>
+                          </a:solidFill>
+                          <a:latin typeface="Calibri"/>
+                        </a:rPr>
+                        <a:t>D60 IBP higher — C8–C9 lights removed</a:t>
+                      </a:r>
+                    </a:p>
+                  </a:txBody>
+                  <a:tcPr>
+                    <a:solidFill>
+                      <a:srgbClr val="FFFFFF"/>
+                    </a:solidFill>
+                  </a:tcPr>
+                </a:tc>
+              </a:tr>
+              <a:tr h="438912">
+                <a:tc>
+                  <a:txBody>
+                    <a:bodyPr/>
+                    <a:lstStyle/>
+                    <a:p>
+                      <a:r>
+                        <a:rPr sz="1200" b="0">
+                          <a:solidFill>
+                            <a:srgbClr val="141414"/>
+                          </a:solidFill>
+                          <a:latin typeface="Calibri"/>
+                        </a:rPr>
+                        <a:t>Heart (giant)</a:t>
+                      </a:r>
+                    </a:p>
+                  </a:txBody>
+                  <a:tcPr>
+                    <a:solidFill>
+                      <a:srgbClr val="F7F7F7"/>
+                    </a:solidFill>
+                  </a:tcPr>
+                </a:tc>
+                <a:tc>
+                  <a:txBody>
+                    <a:bodyPr/>
+                    <a:lstStyle/>
+                    <a:p>
+                      <a:r>
+                        <a:rPr sz="1200" b="0">
+                          <a:solidFill>
+                            <a:srgbClr val="141414"/>
+                          </a:solidFill>
+                          <a:latin typeface="Calibri"/>
+                        </a:rPr>
+                        <a:t>8.58 + 10.53 (twin)</a:t>
+                      </a:r>
+                    </a:p>
+                  </a:txBody>
+                  <a:tcPr>
+                    <a:solidFill>
+                      <a:srgbClr val="F7F7F7"/>
+                    </a:solidFill>
+                  </a:tcPr>
+                </a:tc>
+                <a:tc>
+                  <a:txBody>
+                    <a:bodyPr/>
+                    <a:lstStyle/>
+                    <a:p>
+                      <a:r>
+                        <a:rPr sz="1200" b="0">
+                          <a:solidFill>
+                            <a:srgbClr val="141414"/>
+                          </a:solidFill>
+                          <a:latin typeface="Calibri"/>
+                        </a:rPr>
+                        <a:t>10.87 (one mountain)</a:t>
+                      </a:r>
+                    </a:p>
+                  </a:txBody>
+                  <a:tcPr>
+                    <a:solidFill>
+                      <a:srgbClr val="F7F7F7"/>
+                    </a:solidFill>
+                  </a:tcPr>
+                </a:tc>
+                <a:tc>
+                  <a:txBody>
+                    <a:bodyPr/>
+                    <a:lstStyle/>
+                    <a:p>
+                      <a:r>
+                        <a:rPr sz="1200" b="0">
+                          <a:solidFill>
+                            <a:srgbClr val="141414"/>
+                          </a:solidFill>
+                          <a:latin typeface="Calibri"/>
+                        </a:rPr>
+                        <a:t>Cut centered C10/C11 vs C11–C12</a:t>
+                      </a:r>
+                    </a:p>
+                  </a:txBody>
+                  <a:tcPr>
+                    <a:solidFill>
+                      <a:srgbClr val="F7F7F7"/>
+                    </a:solidFill>
+                  </a:tcPr>
+                </a:tc>
+              </a:tr>
+              <a:tr h="438912">
+                <a:tc>
+                  <a:txBody>
+                    <a:bodyPr/>
+                    <a:lstStyle/>
+                    <a:p>
+                      <a:r>
+                        <a:rPr sz="1200" b="0">
+                          <a:solidFill>
+                            <a:srgbClr val="141414"/>
+                          </a:solidFill>
+                          <a:latin typeface="Calibri"/>
+                        </a:rPr>
+                        <a:t>Main mass</a:t>
+                      </a:r>
+                    </a:p>
+                  </a:txBody>
+                  <a:tcPr>
+                    <a:solidFill>
+                      <a:srgbClr val="FFFFFF"/>
+                    </a:solidFill>
+                  </a:tcPr>
+                </a:tc>
+                <a:tc>
+                  <a:txBody>
+                    <a:bodyPr/>
+                    <a:lstStyle/>
+                    <a:p>
+                      <a:r>
+                        <a:rPr sz="1200" b="0">
+                          <a:solidFill>
+                            <a:srgbClr val="141414"/>
+                          </a:solidFill>
+                          <a:latin typeface="Calibri"/>
+                        </a:rPr>
+                        <a:t>7 – 11 min</a:t>
+                      </a:r>
+                    </a:p>
+                  </a:txBody>
+                  <a:tcPr>
+                    <a:solidFill>
+                      <a:srgbClr val="FFFFFF"/>
+                    </a:solidFill>
+                  </a:tcPr>
+                </a:tc>
+                <a:tc>
+                  <a:txBody>
+                    <a:bodyPr/>
+                    <a:lstStyle/>
+                    <a:p>
+                      <a:r>
+                        <a:rPr sz="1200" b="0">
+                          <a:solidFill>
+                            <a:srgbClr val="141414"/>
+                          </a:solidFill>
+                          <a:latin typeface="Calibri"/>
+                        </a:rPr>
+                        <a:t>9 – 12.5 min</a:t>
+                      </a:r>
+                    </a:p>
+                  </a:txBody>
+                  <a:tcPr>
+                    <a:solidFill>
+                      <a:srgbClr val="FFFFFF"/>
+                    </a:solidFill>
+                  </a:tcPr>
+                </a:tc>
+                <a:tc>
+                  <a:txBody>
+                    <a:bodyPr/>
+                    <a:lstStyle/>
+                    <a:p>
+                      <a:r>
+                        <a:rPr sz="1200" b="0">
+                          <a:solidFill>
+                            <a:srgbClr val="141414"/>
+                          </a:solidFill>
+                          <a:latin typeface="Calibri"/>
+                        </a:rPr>
+                        <a:t>BP 163–187 °C vs 180–220 °C</a:t>
+                      </a:r>
+                    </a:p>
+                  </a:txBody>
+                  <a:tcPr>
+                    <a:solidFill>
+                      <a:srgbClr val="FFFFFF"/>
+                    </a:solidFill>
+                  </a:tcPr>
+                </a:tc>
+              </a:tr>
+              <a:tr h="438912">
+                <a:tc>
+                  <a:txBody>
+                    <a:bodyPr/>
+                    <a:lstStyle/>
+                    <a:p>
+                      <a:r>
+                        <a:rPr sz="1200" b="0">
+                          <a:solidFill>
+                            <a:srgbClr val="141414"/>
+                          </a:solidFill>
+                          <a:latin typeface="Calibri"/>
+                        </a:rPr>
+                        <a:t>Shape</a:t>
+                      </a:r>
+                    </a:p>
+                  </a:txBody>
+                  <a:tcPr>
+                    <a:solidFill>
+                      <a:srgbClr val="F7F7F7"/>
+                    </a:solidFill>
+                  </a:tcPr>
+                </a:tc>
+                <a:tc>
+                  <a:txBody>
+                    <a:bodyPr/>
+                    <a:lstStyle/>
+                    <a:p>
+                      <a:r>
+                        <a:rPr sz="1200" b="0">
+                          <a:solidFill>
+                            <a:srgbClr val="141414"/>
+                          </a:solidFill>
+                          <a:latin typeface="Calibri"/>
+                        </a:rPr>
+                        <a:t>Two tall spikes</a:t>
+                      </a:r>
+                    </a:p>
+                  </a:txBody>
+                  <a:tcPr>
+                    <a:solidFill>
+                      <a:srgbClr val="F7F7F7"/>
+                    </a:solidFill>
+                  </a:tcPr>
+                </a:tc>
+                <a:tc>
+                  <a:txBody>
+                    <a:bodyPr/>
+                    <a:lstStyle/>
+                    <a:p>
+                      <a:r>
+                        <a:rPr sz="1200" b="0">
+                          <a:solidFill>
+                            <a:srgbClr val="141414"/>
+                          </a:solidFill>
+                          <a:latin typeface="Calibri"/>
+                        </a:rPr>
+                        <a:t>Late dense hump</a:t>
+                      </a:r>
+                    </a:p>
+                  </a:txBody>
+                  <a:tcPr>
+                    <a:solidFill>
+                      <a:srgbClr val="F7F7F7"/>
+                    </a:solidFill>
+                  </a:tcPr>
+                </a:tc>
+                <a:tc>
+                  <a:txBody>
+                    <a:bodyPr/>
+                    <a:lstStyle/>
+                    <a:p>
+                      <a:r>
+                        <a:rPr sz="1200" b="0">
+                          <a:solidFill>
+                            <a:srgbClr val="141414"/>
+                          </a:solidFill>
+                          <a:latin typeface="Calibri"/>
+                        </a:rPr>
+                        <a:t>Heavier isomers cluster later</a:t>
+                      </a:r>
+                    </a:p>
+                  </a:txBody>
+                  <a:tcPr>
+                    <a:solidFill>
+                      <a:srgbClr val="F7F7F7"/>
+                    </a:solidFill>
+                  </a:tcPr>
+                </a:tc>
+              </a:tr>
+            </a:tbl>
+          </a:graphicData>
+        </a:graphic>
+      </p:graphicFrame>
     </p:spTree>
   </p:cSld>
   <p:clrMapOvr>

</xml_diff>